<commit_message>
docs: add compression review speaker script
</commit_message>
<xml_diff>
--- a/slide-deck/vehicle-pose-compression-review/vehicle-pose-compression-review.pptx
+++ b/slide-deck/vehicle-pose-compression-review/vehicle-pose-compression-review.pptx
@@ -504,77 +504,21 @@
           <a:p>
             <a:r>
               <a:rPr lang="en-US" dirty="0"/>
-              <a:t>Create a presentation slide image following these guidelines:
-## Image Specifications
-- **Type**: Presentation slide
-- **Aspect Ratio**: 16:9 (landscape)
-- **Style**: Professional slide deck
-## Core Persona: The Architect
-You are "The Architect" - a master visual storyteller creating presentation slides. Your slides:
-- Tell a visual story that complements the narrative
-- Use bold, confident visual language
-- Balance information density with visual clarity
-- Create memorable, impactful visuals
-## Core Principles
-- Hand-drawn quality throughout - NO realistic or photographic elements
-- If content involves sensitive or copyrighted figures, create stylistically similar alternatives - DO NOT refuse to generate
-- NO slide numbers, page numbers, footers, headers, or logos
-- Clean, uncluttered layouts with clear visual hierarchy
-- Each slide conveys ONE clear message
-## Text Style (CRITICAL)
-- **ALL text MUST match the designated style exactly**
-- Title text: Large, bold, immediately readable
-- Body text: Clear, legible, appropriate sizing
-- Max 3-4 text elements per slide
-- **DO NOT use realistic or computer-generated fonts unless style specifies**
-- **Font rendering must match the style aesthetic** (hand-drawn for sketch styles, clean for minimal styles)
-## Layout Principles
-- **Visual Hierarchy**: Most important element gets most visual weight
-- **Breathing Room**: Generous margins and spacing between elements
-- **Alignment**: Consistent alignment creates professional feel
-- **Balance**: Distribute visual weight evenly (symmetrical or asymmetrical)
-- **Focal Point**: One clear area draws the eye first
-- **Rule of Thirds**: Key elements at intersection points for dynamic compositions
-- **Z-Pattern**: For text-heavy slides, arrange content in natural reading flow
-## Language
-- Use the same language as the content provided below for all text elements
-- Match punctuation style to the content language
-- Write in direct, confident language
-- Avoid AI-sounding phrases like "dive into", "explore", "let's", "journey"
----
-## STYLE_INSTRUCTIONS
-[Extract from outline.md - do NOT re-read style files]
-The STYLE_INSTRUCTIONS block from the outline contains:
-- Design Aesthetic
-- Background (Texture + Base Color)
-- Typography (Headlines + Body descriptions)
-- Color Palette (with hex codes)
-- Visual Elements
-- Density Guidelines
-- Style Rules (Do/Don't)
-Copy the entire `&lt;STYLE_INSTRUCTIONS&gt;...&lt;/STYLE_INSTRUCTIONS&gt;` block from the outline here.
----
-## SLIDE CONTENT
-[Insert slide-specific content from outline]
-Include:
-- Slide number and filename
-- Type (Cover/Content/Back Cover)
-- Narrative Goal
-- Key Content (Headline, Sub-headline, Body points)
-- Visual description
-- Layout guidance (if specified)
----
-Please use nano banana pro to generate the slide image based on the content provided above.
----
-使用 outline.md 的完整 STYLE_INSTRUCTIONS。
-生成 16:9 中文技术评审幻灯片。标题“26+ 组实验后的硬结论：参数更少 ≠ GPU 更快”。
-副标题包含“RTX 3090 Ti · 640 · batch=1 · fused FP16 · paired AB/BA · 3,606 图验证”。
-采用 dashboard 布局：左侧实验地图按 512 分辨率、通道剪枝、BN-scale、串行深度、
-部署分支五类排列；每类标注代表性结果和 PASS/FAIL。右侧显示两道硬门禁：
-延迟下降 ≥10%，Box/Pose ≥0.64761/0.49455。底部标出 baseline 0.665/0.514。
-突出“参数最多 -52% 但延迟无收益”和“减少串行 kernel 才真正有效”。
-所有数字必须精确，不使用照片，不添加页码、logo 或脚注。
-</a:t>
+              <a:t>## 第 1 页｜实验全景：先统一评判标准
+**建议时长：2 分 30 秒**
+**讲述目标：** 让听众先理解实验规模、统一口径和双门禁，避免只看某一个漂亮数字。
+### 逐字稿
+这一页先回答两个问题：我们到底试了什么，以及什么结果才算真正成功。
+整个项目只讨论模型压缩和结构剪枝，不引入 TensorRT。实验覆盖了部署态分支裁剪、骨干和颈部轻量化、检测与姿态塔减深、ClassLite 分类塔，以及对应的监督恢复和知识蒸馏。评估始终使用同一套三门禁：第一，速度必须在同进程 paired AB/BA 条件下提升至少 10%；第二，精度不能低于基线 Box mAP 0.64761、Pose mAP 0.49455；第三，峰值 CUDA 显存必须可复现地下降。
+这里必须强调：参数量和 FLOPs 只是结构指标，不是 latency 的可靠代理。实验里有参数减少超过一半、但真实推理反而没有加速的路线。原因包括 tensor slicing、定向搬运、padding 和 kernel launch 行为变化。因此，所有速度结论都来自 fused FP16、batch 1、640 输入下的 paired 实测，绝不跨进程拼接两个数字。
+精度则来自完整 3,606 张图、11,569 个实例的验证集，至少同时看 Box、Pose、PCK 和 NME。内存由独立进程测量模型加载、输入后和推理峰值，避免训练显存与推理显存混用。
+从实验地图看，大部分结构剪枝都在速度或精度门禁前停止。真正值得重点讨论的是右侧两组：一组是部署态分支裁剪，它保住了精度和输出一致性，主要优化体积与显存；另一组是 ClassLite52，它跨过了 10% 速度线，但尚未恢复到精度基线。
+### 讲述提醒
+- 不要说“已经同时完成速度、精度和显存目标”。
+- “部署态方案”与“结构研究候选”必须分开定性。
+- 若被问到延迟绝对值，先说明只有同一次 paired 测量中的相对值可比较。
+### 转场
+接下来把这两组最有工程价值的结果放在同一页，分别看它们解决了什么、又没有解决什么。</a:t>
             </a:r>
             <a:endParaRPr lang="en-US" dirty="0"/>
           </a:p>
@@ -662,78 +606,24 @@
           <a:p>
             <a:r>
               <a:rPr lang="en-US" dirty="0"/>
-              <a:t>Create a presentation slide image following these guidelines:
-## Image Specifications
-- **Type**: Presentation slide
-- **Aspect Ratio**: 16:9 (landscape)
-- **Style**: Professional slide deck
-## Core Persona: The Architect
-You are "The Architect" - a master visual storyteller creating presentation slides. Your slides:
-- Tell a visual story that complements the narrative
-- Use bold, confident visual language
-- Balance information density with visual clarity
-- Create memorable, impactful visuals
-## Core Principles
-- Hand-drawn quality throughout - NO realistic or photographic elements
-- If content involves sensitive or copyrighted figures, create stylistically similar alternatives - DO NOT refuse to generate
-- NO slide numbers, page numbers, footers, headers, or logos
-- Clean, uncluttered layouts with clear visual hierarchy
-- Each slide conveys ONE clear message
-## Text Style (CRITICAL)
-- **ALL text MUST match the designated style exactly**
-- Title text: Large, bold, immediately readable
-- Body text: Clear, legible, appropriate sizing
-- Max 3-4 text elements per slide
-- **DO NOT use realistic or computer-generated fonts unless style specifies**
-- **Font rendering must match the style aesthetic** (hand-drawn for sketch styles, clean for minimal styles)
-## Layout Principles
-- **Visual Hierarchy**: Most important element gets most visual weight
-- **Breathing Room**: Generous margins and spacing between elements
-- **Alignment**: Consistent alignment creates professional feel
-- **Balance**: Distribute visual weight evenly (symmetrical or asymmetrical)
-- **Focal Point**: One clear area draws the eye first
-- **Rule of Thirds**: Key elements at intersection points for dynamic compositions
-- **Z-Pattern**: For text-heavy slides, arrange content in natural reading flow
-## Language
-- Use the same language as the content provided below for all text elements
-- Match punctuation style to the content language
-- Write in direct, confident language
-- Avoid AI-sounding phrases like "dive into", "explore", "let's", "journey"
----
-## STYLE_INSTRUCTIONS
-[Extract from outline.md - do NOT re-read style files]
-The STYLE_INSTRUCTIONS block from the outline contains:
-- Design Aesthetic
-- Background (Texture + Base Color)
-- Typography (Headlines + Body descriptions)
-- Color Palette (with hex codes)
-- Visual Elements
-- Density Guidelines
-- Style Rules (Do/Don't)
-Copy the entire `&lt;STYLE_INSTRUCTIONS&gt;...&lt;/STYLE_INSTRUCTIONS&gt;` block from the outline here.
----
-## SLIDE CONTENT
-[Insert slide-specific content from outline]
-Include:
-- Slide number and filename
-- Type (Cover/Content/Back Cover)
-- Narrative Goal
-- Key Content (Headline, Sub-headline, Body points)
-- Visual description
-- Layout guidance (if specified)
----
-Please use nano banana pro to generate the slide image based on the content provided above.
----
-使用 outline.md 的完整 STYLE_INSTRUCTIONS。
-生成 16:9 中文技术评审幻灯片。标题“两组最佳方案：一组可交付，一组仍是研究候选”。
-左右二元对比：
-左卡 Deployment-only，绿色 SHIP，参数 -26.96%、文件 -26.59%、峰值显存 -8.99%、
-Box/Pose 0.665/0.514、输出逐元素一致、延迟仅快 0.19%。
-右卡 ClassLite52，琥珀色 RESEARCH，6.02302→5.38792 ms、快 10.54459%、
-参数约 -4.28%、最佳 0.62507/0.46795、精度差距 0.02254/0.02660。
-中央小坐标轴表示“精度保持”和“延迟收益”。明确两组解决不同目标。
-所有数字必须精确，不使用照片，不添加页码、logo 或脚注。
-</a:t>
+              <a:t>## 第 2 页｜最佳两组：可交付方案与速度候选
+**建议时长：3 分钟**
+**讲述目标：** 用准确措辞突出两组最优结果，同时说明二者并不是同一种“成功”。
+### 逐字稿
+左侧是当前可以交付的 deployment-only 分支裁剪。它删除部署时不需要的一对多分支，参数量下降 26.96%，文件体积下降 26.59%，峰值显存下降 8.99%。完整验证精度保持在 Box 0.665、Pose 0.514，输出做到 bit-exact。
+但它不是速度方案：paired latency 只改善 0.19%，没有达到 10% 门槛。因此它的正确定位是精度等价的体积和内存压缩，适合先进入工程交付，而不能宣传为推理加速。
+右侧是 ClassLite52。这个结构保留分类塔第一组 depthwise 加 pointwise，只把第二组替换成 pointwise，并把中间宽度压到 52。它的 paired fused-FP16 延迟从 6.02302 毫秒下降到 5.38792 毫秒，提升 10.54459%，刚刚越过速度门槛；参数量下降 4.28%。
+精度方面，当前最好结果是 Box 0.62507、Pose 0.46795。相对基线仍差 0.02254 和 0.02660，因此精度门禁明确失败。我们尝试了无 KD 监督恢复、输出蒸馏、特征蒸馏、只训练头部和低学习率联合精修。最好点仍来自无 KD 的监督恢复，后续多轮微调没有形成稳定增益。这说明问题不只是训练轮数不足，更可能是分类塔容量与双任务耦合带来的结构上限。
+所以这两组形成清晰分工：deployment-only 是现在就能交付的内存与体积方案；ClassLite52 是速度过线、但必须继续解决精度的研究候选。当前不存在一组同时通过全部门禁的结构剪枝方案。
+### 可能追问
+**为什么 ClassLite52 参数只少 4.28%，却能快 10.54%？**  
+因为 latency 由实际 kernel 形态、内存访问和调度共同决定，参数比例并不线性映射到延迟。
+**为什么不继续重复微调？**  
+已有监督恢复、KD 和不同冻结范围的结果都收敛到相近平台；继续相同配方的边际信息价值很低。
+**现在应该选哪组？**  
+若目标是近期可靠交付，选 deployment-only；若目标是探索速度上限，保留 ClassLite52 作为结构搜索起点。
+### 转场
+最后一页把失败原因转成工程规则，并明确下一轮应该改变什么，而不是继续重复同一种微调。</a:t>
             </a:r>
             <a:endParaRPr lang="en-US" dirty="0"/>
           </a:p>
@@ -821,78 +711,22 @@
           <a:p>
             <a:r>
               <a:rPr lang="en-US" dirty="0"/>
-              <a:t>Create a presentation slide image following these guidelines:
-## Image Specifications
-- **Type**: Presentation slide
-- **Aspect Ratio**: 16:9 (landscape)
-- **Style**: Professional slide deck
-## Core Persona: The Architect
-You are "The Architect" - a master visual storyteller creating presentation slides. Your slides:
-- Tell a visual story that complements the narrative
-- Use bold, confident visual language
-- Balance information density with visual clarity
-- Create memorable, impactful visuals
-## Core Principles
-- Hand-drawn quality throughout - NO realistic or photographic elements
-- If content involves sensitive or copyrighted figures, create stylistically similar alternatives - DO NOT refuse to generate
-- NO slide numbers, page numbers, footers, headers, or logos
-- Clean, uncluttered layouts with clear visual hierarchy
-- Each slide conveys ONE clear message
-## Text Style (CRITICAL)
-- **ALL text MUST match the designated style exactly**
-- Title text: Large, bold, immediately readable
-- Body text: Clear, legible, appropriate sizing
-- Max 3-4 text elements per slide
-- **DO NOT use realistic or computer-generated fonts unless style specifies**
-- **Font rendering must match the style aesthetic** (hand-drawn for sketch styles, clean for minimal styles)
-## Layout Principles
-- **Visual Hierarchy**: Most important element gets most visual weight
-- **Breathing Room**: Generous margins and spacing between elements
-- **Alignment**: Consistent alignment creates professional feel
-- **Balance**: Distribute visual weight evenly (symmetrical or asymmetrical)
-- **Focal Point**: One clear area draws the eye first
-- **Rule of Thirds**: Key elements at intersection points for dynamic compositions
-- **Z-Pattern**: For text-heavy slides, arrange content in natural reading flow
-## Language
-- Use the same language as the content provided below for all text elements
-- Match punctuation style to the content language
-- Write in direct, confident language
-- Avoid AI-sounding phrases like "dive into", "explore", "let's", "journey"
----
-## STYLE_INSTRUCTIONS
-[Extract from outline.md - do NOT re-read style files]
-The STYLE_INSTRUCTIONS block from the outline contains:
-- Design Aesthetic
-- Background (Texture + Base Color)
-- Typography (Headlines + Body descriptions)
-- Color Palette (with hex codes)
-- Visual Elements
-- Density Guidelines
-- Style Rules (Do/Don't)
-Copy the entire `&lt;STYLE_INSTRUCTIONS&gt;...&lt;/STYLE_INSTRUCTIONS&gt;` block from the outline here.
----
-## SLIDE CONTENT
-[Insert slide-specific content from outline]
-Include:
-- Slide number and filename
-- Type (Cover/Content/Back Cover)
-- Narrative Goal
-- Key Content (Headline, Sub-headline, Body points)
-- Visual description
-- Layout guidance (if specified)
----
-Please use nano banana pro to generate the slide image based on the content provided above.
----
-使用 outline.md 的完整 STYLE_INSTRUCTIONS。
-生成 16:9 中文技术评审幻灯片。标题“工程决策：先交付内存压缩，停止重复微调 ClassLite52”。
-横向三阶段证据链：
-1) 失败机制：参数量不是延迟代理；分类置信度同时影响 Box/Pose；
-2) 已证实规则：冻结 BN 统计、纯监督优于当前 KD、拒绝简单 slicing；
-3) 下一步：保留完整分类塔，从骨干/颈部减少串行 kernel，必须重新通过 paired
-latency、完整精度和显存三门禁。
-底部决策条：SHIP deployment-only；HOLD ClassLite52。
-技术蓝图风格，精确直线和工程标签，不使用照片，不添加页码、logo 或脚注。
-</a:t>
+              <a:t>## 第 3 页｜工程决策：先交付，再改变搜索方向
+**建议时长：2 分 30 秒**
+**讲述目标：** 给出可执行决策、可靠性边界和下一轮结构搜索方向。
+### 逐字稿
+复盘后有三个核心失败机制。
+第一，参数量不是 latency 代理。某些方案虽然参数减少很多，但引入了不利的 tensor slicing、搬运和 padding，实际 kernel 行为更差。第二，分类塔减深会同时影响检测框置信度和姿态任务，因为两个任务共享特征与样本分配信号。第三，异构教师的特征蒸馏并没有稳定恢复容量损失；在当前实验中，纯监督恢复反而给出了 ClassLite52 的最好点。
+这些结果沉淀成三条工程规则。第一，冻结参数不等于冻结运行行为，必须同时固定 BatchNorm running statistics。第二，拒绝简单 tensor slicing，权重迁移必须按结构语义处理，包括 C2f 投影折叠、定向搬运和必要的 padding。第三，先跑速度 gate，再决定是否投入训练；所有延迟都做 paired AB/BA，避免时钟和系统状态偏差。
+下一轮不再重复微调 ClassLite52，而是改变结构搜索空间：保留完整分类塔，避免直接破坏最敏感的分类容量；优先从骨干或颈部寻找能落到高效 kernel 的减法；每个候选重新执行延迟、完整精度和 CUDA 峰值三门禁。
+可靠性边界也要说清楚：latency 是 fused FP16、batch 1、640 输入下的同进程 paired 结果；accuracy 来自完整 3,606 图和 11,569 实例；memory 来自独立进程；CSV、JSON、训练日志和停止原因全部留档。这些口径让结论可审计，但不意味着换硬件后绝对毫秒数不变。
+最终决策是：交付 deployment-only 分支裁剪，作为精度等价的体积和显存优化；暂停重复微调 ClassLite52，把它保留为速度过线的研究基线，直到新的结构能够通过精度门禁。
+### 收尾句
+这轮实验最重要的产出不只是一组数字，而是一套可复用的压缩判定流程：先用真实延迟筛结构，再用完整精度和独立显存决定能否交付。
+### 讨论入口
+- 若优先交付：确认 deployment-only 的目标平台回归计划。
+- 若继续研究：评审下一轮骨干/颈部 kernel-friendly 搜索预算。
+- 若更换硬件：重新执行 paired latency 与独立 CUDA memory，不复用绝对值。</a:t>
             </a:r>
             <a:endParaRPr lang="en-US" dirty="0"/>
           </a:p>

</xml_diff>

<commit_message>
feat: add P5 balanced pruning result
</commit_message>
<xml_diff>
--- a/slide-deck/vehicle-pose-compression-review/vehicle-pose-compression-review.pptx
+++ b/slide-deck/vehicle-pose-compression-review/vehicle-pose-compression-review.pptx
@@ -512,10 +512,10 @@
 整个项目只讨论模型压缩和结构剪枝，不引入 TensorRT。实验覆盖了部署态分支裁剪、骨干和颈部轻量化、检测与姿态塔减深、ClassLite 分类塔，以及对应的监督恢复和知识蒸馏。评估始终使用同一套三门禁：第一，速度必须在同进程 paired AB/BA 条件下提升至少 10%；第二，精度不能低于基线 Box mAP 0.64761、Pose mAP 0.49455；第三，峰值 CUDA 显存必须可复现地下降。
 这里必须强调：参数量和 FLOPs 只是结构指标，不是 latency 的可靠代理。实验里有参数减少超过一半、但真实推理反而没有加速的路线。原因包括 tensor slicing、定向搬运、padding 和 kernel launch 行为变化。因此，所有速度结论都来自 fused FP16、batch 1、640 输入下的 paired 实测，绝不跨进程拼接两个数字。
 精度则来自完整 3,606 张图、11,569 个实例的验证集，至少同时看 Box、Pose、PCK 和 NME。内存由独立进程测量模型加载、输入后和推理峰值，避免训练显存与推理显存混用。
-从实验地图看，大部分结构剪枝都在速度或精度门禁前停止。真正值得重点讨论的是右侧两组：一组是部署态分支裁剪，它保住了精度和输出一致性，主要优化体积与显存；另一组是 ClassLite52，它跨过了 10% 速度线，但尚未恢复到精度基线。
+从实验地图看，大部分结构剪枝都在速度或精度门禁前停止。新增的 P5-Zero 改变了最终结论：它只移除 backbone P5 和 neck P5 的内部 bottleneck，完整保留 P3、P4 和三个任务塔；最终同时通过速度、精度和显存门禁。右侧两组因此分别代表体积优先的 deployment-only 和速度—精度平衡的 P5-Zero。
 ### 讲述提醒
 - 不要说“已经同时完成速度、精度和显存目标”。
-- “部署态方案”与“结构研究候选”必须分开定性。
+- “部署态体积方案”与“结构加速方案”必须按各自收益边界定性。
 - 若被问到延迟绝对值，先说明只有同一次 paired 测量中的相对值可比较。
 ### 转场
 接下来把这两组最有工程价值的结果放在同一页，分别看它们解决了什么、又没有解决什么。</a:t>
@@ -606,24 +606,24 @@
           <a:p>
             <a:r>
               <a:rPr lang="en-US" dirty="0"/>
-              <a:t>## 第 2 页｜最佳两组：可交付方案与速度候选
+              <a:t>## 第 2 页｜最佳两组：体积优先与速度—精度平衡
 **建议时长：3 分钟**
-**讲述目标：** 用准确措辞突出两组最优结果，同时说明二者并不是同一种“成功”。
+**讲述目标：** 用统一门禁突出两组可交付结果，并说明各自适用目标。
 ### 逐字稿
 左侧是当前可以交付的 deployment-only 分支裁剪。它删除部署时不需要的一对多分支，参数量下降 26.96%，文件体积下降 26.59%，峰值显存下降 8.99%。完整验证精度保持在 Box 0.665、Pose 0.514，输出做到 bit-exact。
 但它不是速度方案：paired latency 只改善 0.19%，没有达到 10% 门槛。因此它的正确定位是精度等价的体积和内存压缩，适合先进入工程交付，而不能宣传为推理加速。
-右侧是 ClassLite52。这个结构保留分类塔第一组 depthwise 加 pointwise，只把第二组替换成 pointwise，并把中间宽度压到 52。它的 paired fused-FP16 延迟从 6.02302 毫秒下降到 5.38792 毫秒，提升 10.54459%，刚刚越过速度门槛；参数量下降 4.28%。
-精度方面，当前最好结果是 Box 0.62507、Pose 0.46795。相对基线仍差 0.02254 和 0.02660，因此精度门禁明确失败。我们尝试了无 KD 监督恢复、输出蒸馏、特征蒸馏、只训练头部和低学习率联合精修。最好点仍来自无 KD 的监督恢复，后续多轮微调没有形成稳定增益。这说明问题不只是训练轮数不足，更可能是分类塔容量与双任务耦合带来的结构上限。
-所以这两组形成清晰分工：deployment-only 是现在就能交付的内存与体积方案；ClassLite52 是速度过线、但必须继续解决精度的研究候选。当前不存在一组同时通过全部门禁的结构剪枝方案。
+右侧是 P5-Zero 平衡结构。它保留 LitePSA、P3/P4 和完整的 Box、Class、Pose 塔，只把 backbone P5 与 neck P5 两个 C2f 的内部 bottleneck 数量设为零。权重迁移采用投影折叠，605 个张量直接复制、2 个张量折叠，无 missing 或 unexpected key。
+最终 paired fused-FP16 延迟从 5.94537 毫秒下降到 5.06345 毫秒，提升 14.83371%；fused 参数下降 15.14%。完整 3,606 图验证得到 Box 0.66254、Pose 0.49592，分别高于门槛 0.01493 和 0.00137。模型驻留显存下降 6.29%，推理峰值显存下降 5.02%，所以三门禁全部通过。
+所以这两组形成清晰分工：deployment-only 的参数和文件收益更大，并保持输出 bit-exact；P5-Zero 提供显著速度提升，同时保持门槛以上的 Box/Pose 精度。两者都可交付，但目标不同。
 ### 可能追问
-**为什么 ClassLite52 参数只少 4.28%，却能快 10.54%？**  
-因为 latency 由实际 kernel 形态、内存访问和调度共同决定，参数比例并不线性映射到延迟。
-**为什么不继续重复微调？**  
-已有监督恢复、KD 和不同冻结范围的结果都收敛到相近平台；继续相同配方的边际信息价值很低。
+**为什么选择 P5，而不是继续压缩 P3/P4 或任务塔？**
+P5 处于低分辨率语义层，减少串行层能降低 kernel 数量，同时对高分辨率定位细节和分类置信度破坏更小。
+**Pose 余量较小，是否可靠？**
+当前门禁内通过，但余量只有 0.00137；因此报告明确限定为 RTX 3090 Ti、PyTorch fused FP16 的当前验证口径，换硬件或数据版本必须重跑三门禁。
 **现在应该选哪组？**  
-若目标是近期可靠交付，选 deployment-only；若目标是探索速度上限，保留 ClassLite52 作为结构搜索起点。
+若目标是极致体积且不要求显著加速，选 deployment-only；若目标是速度、精度和显存综合平衡，选 P5-Zero。
 ### 转场
-最后一页把失败原因转成工程规则，并明确下一轮应该改变什么，而不是继续重复同一种微调。</a:t>
+最后一页把失败原因和本次成功机制转成可复用的工程规则与交付边界。</a:t>
             </a:r>
             <a:endParaRPr lang="en-US" dirty="0"/>
           </a:p>
@@ -711,21 +711,21 @@
           <a:p>
             <a:r>
               <a:rPr lang="en-US" dirty="0"/>
-              <a:t>## 第 3 页｜工程决策：先交付，再改变搜索方向
+              <a:t>## 第 3 页｜工程决策：通过三门禁，固化可复用交付
 **建议时长：2 分 30 秒**
 **讲述目标：** 给出可执行决策、可靠性边界和下一轮结构搜索方向。
 ### 逐字稿
 复盘后有三个核心失败机制。
-第一，参数量不是 latency 代理。某些方案虽然参数减少很多，但引入了不利的 tensor slicing、搬运和 padding，实际 kernel 行为更差。第二，分类塔减深会同时影响检测框置信度和姿态任务，因为两个任务共享特征与样本分配信号。第三，异构教师的特征蒸馏并没有稳定恢复容量损失；在当前实验中，纯监督恢复反而给出了 ClassLite52 的最好点。
+第一，参数量不是 latency 代理。某些方案虽然参数减少很多，实际 kernel 行为却没有改善。第二，分类塔减深会同时影响检测框置信度和姿态任务，因此不适合作为这次的主压缩点。第三，低分辨率 P5 层减少串行 bottleneck，能在保留 P3/P4 定位细节和完整任务塔的同时获得稳定速度收益。
 这些结果沉淀成三条工程规则。第一，冻结参数不等于冻结运行行为，必须同时固定 BatchNorm running statistics。第二，拒绝简单 tensor slicing，权重迁移必须按结构语义处理，包括 C2f 投影折叠、定向搬运和必要的 padding。第三，先跑速度 gate，再决定是否投入训练；所有延迟都做 paired AB/BA，避免时钟和系统状态偏差。
-下一轮不再重复微调 ClassLite52，而是改变结构搜索空间：保留完整分类塔，避免直接破坏最敏感的分类容量；优先从骨干或颈部寻找能落到高效 kernel 的减法；每个候选重新执行延迟、完整精度和 CUDA 峰值三门禁。
+交付阶段冻结 P5-Zero 结构、训练配置和最终 checkpoint，并在目标设备重新执行三门禁。后续探索只做小步消融：每次只改变一个串行深度点，先跑 paired 延迟，再决定是否训练，最后跑完整精度与独立 CUDA memory。
 可靠性边界也要说清楚：latency 是 fused FP16、batch 1、640 输入下的同进程 paired 结果；accuracy 来自完整 3,606 图和 11,569 实例；memory 来自独立进程；CSV、JSON、训练日志和停止原因全部留档。这些口径让结论可审计，但不意味着换硬件后绝对毫秒数不变。
-最终决策是：交付 deployment-only 分支裁剪，作为精度等价的体积和显存优化；暂停重复微调 ClassLite52，把它保留为速度过线的研究基线，直到新的结构能够通过精度门禁。
+最终决策是：deployment-only 作为精度等价的体积和显存方案继续保留；P5-Zero 作为速度—精度平衡方案进入交付。ClassLite52 保留为失败对照，不再重复微调。
 ### 收尾句
 这轮实验最重要的产出不只是一组数字，而是一套可复用的压缩判定流程：先用真实延迟筛结构，再用完整精度和独立显存决定能否交付。
 ### 讨论入口
-- 若优先交付：确认 deployment-only 的目标平台回归计划。
-- 若继续研究：评审下一轮骨干/颈部 kernel-friendly 搜索预算。
+- 若优先交付：确认 P5-Zero checkpoint 与目标平台回归计划。
+- 若继续研究：以 P5-Zero 为锚点，只做可回退的小步 kernel-depth 消融。
 - 若更换硬件：重新执行 paired latency 与独立 CUDA memory，不复用绝对值。</a:t>
             </a:r>
             <a:endParaRPr lang="en-US" dirty="0"/>

</xml_diff>

<commit_message>
docs: finalize P5 pruning review deck
</commit_message>
<xml_diff>
--- a/slide-deck/vehicle-pose-compression-review/vehicle-pose-compression-review.pptx
+++ b/slide-deck/vehicle-pose-compression-review/vehicle-pose-compression-review.pptx
@@ -506,7 +506,7 @@
               <a:rPr lang="en-US" dirty="0"/>
               <a:t>## 第 1 页｜实验全景：先统一评判标准
 **建议时长：2 分 30 秒**
-**讲述目标：** 让听众先理解实验规模、统一口径和双门禁，避免只看某一个漂亮数字。
+**讲述目标：** 让听众先理解实验规模、统一口径和三门禁，避免只看某一个漂亮数字。
 ### 逐字稿
 这一页先回答两个问题：我们到底试了什么，以及什么结果才算真正成功。
 整个项目只讨论模型压缩和结构剪枝，不引入 TensorRT。实验覆盖了部署态分支裁剪、骨干和颈部轻量化、检测与姿态塔减深、ClassLite 分类塔，以及对应的监督恢复和知识蒸馏。评估始终使用同一套三门禁：第一，速度必须在同进程 paired AB/BA 条件下提升至少 10%；第二，精度不能低于基线 Box mAP 0.64761、Pose mAP 0.49455；第三，峰值 CUDA 显存必须可复现地下降。
@@ -514,7 +514,8 @@
 精度则来自完整 3,606 张图、11,569 个实例的验证集，至少同时看 Box、Pose、PCK 和 NME。内存由独立进程测量模型加载、输入后和推理峰值，避免训练显存与推理显存混用。
 从实验地图看，大部分结构剪枝都在速度或精度门禁前停止。新增的 P5-Zero 改变了最终结论：它只移除 backbone P5 和 neck P5 的内部 bottleneck，完整保留 P3、P4 和三个任务塔；最终同时通过速度、精度和显存门禁。右侧两组因此分别代表体积优先的 deployment-only 和速度—精度平衡的 P5-Zero。
 ### 讲述提醒
-- 不要说“已经同时完成速度、精度和显存目标”。
+- 可以说“P5-Zero 在当前 RTX 3090 Ti / PyTorch fused-FP16 口径下通过三门禁”。
+- 不要外推为跨硬件稳定，也不要表述为“相对原始 baseline 完全无精度下降”。
 - “部署态体积方案”与“结构加速方案”必须按各自收益边界定性。
 - 若被问到延迟绝对值，先说明只有同一次 paired 测量中的相对值可比较。
 ### 转场
@@ -613,14 +614,15 @@
 左侧是当前可以交付的 deployment-only 分支裁剪。它删除部署时不需要的一对多分支，参数量下降 26.96%，文件体积下降 26.59%，峰值显存下降 8.99%。完整验证精度保持在 Box 0.665、Pose 0.514，输出做到 bit-exact。
 但它不是速度方案：paired latency 只改善 0.19%，没有达到 10% 门槛。因此它的正确定位是精度等价的体积和内存压缩，适合先进入工程交付，而不能宣传为推理加速。
 右侧是 P5-Zero 平衡结构。它保留 LitePSA、P3/P4 和完整的 Box、Class、Pose 塔，只把 backbone P5 与 neck P5 两个 C2f 的内部 bottleneck 数量设为零。权重迁移采用投影折叠，605 个张量直接复制、2 个张量折叠，无 missing 或 unexpected key。
-最终 paired fused-FP16 延迟从 5.94537 毫秒下降到 5.06345 毫秒，提升 14.83371%；fused 参数下降 15.14%。完整 3,606 图验证得到 Box 0.66254、Pose 0.49592，分别高于门槛 0.01493 和 0.00137。模型驻留显存下降 6.29%，推理峰值显存下降 5.02%，所以三门禁全部通过。
+最终 paired fused-FP16 延迟从 5.94537 毫秒下降到 5.06345 毫秒，提升 14.83371%；fused 参数下降 15.14%。最佳 checkpoint 的完整验证记录为 Box 0.66254、Pose 0.49592，独立的最终 fused-FP16 全量复验为 0.662/0.496，确认均高于门槛。模型驻留显存下降 6.29%，推理峰值显存下降 5.02%，所以三门禁全部通过。
+这里的“通过”是相对发布门槛，不是相对原始 baseline 完全无损：原始 baseline 约为 0.665/0.515。P5-Zero 的工程价值是用可接受的精度预算换取 14.83% 延迟、15.14% 参数和 5.02% 峰值显存收益。
 所以这两组形成清晰分工：deployment-only 的参数和文件收益更大，并保持输出 bit-exact；P5-Zero 提供显著速度提升，同时保持门槛以上的 Box/Pose 精度。两者都可交付，但目标不同。
 ### 可能追问
 **为什么选择 P5，而不是继续压缩 P3/P4 或任务塔？**
 P5 处于低分辨率语义层，减少串行层能降低 kernel 数量，同时对高分辨率定位细节和分类置信度破坏更小。
 **Pose 余量较小，是否可靠？**
 当前门禁内通过，但余量只有 0.00137；因此报告明确限定为 RTX 3090 Ti、PyTorch fused FP16 的当前验证口径，换硬件或数据版本必须重跑三门禁。
-**现在应该选哪组？**  
+**现在应该选哪组？**
 若目标是极致体积且不要求显著加速，选 deployment-only；若目标是速度、精度和显存综合平衡，选 P5-Zero。
 ### 转场
 最后一页把失败原因和本次成功机制转成可复用的工程规则与交付边界。</a:t>

</xml_diff>